<commit_message>
Update prezentacije i dokumentacije
</commit_message>
<xml_diff>
--- a/docs/Prezentacija IOT.pptx
+++ b/docs/Prezentacija IOT.pptx
@@ -112,6 +112,11 @@
       </a:defRPr>
     </a:lvl9pPr>
   </p:defaultTextStyle>
+  <p:extLst>
+    <p:ext uri="{EFAFB233-063F-42B5-8137-9DF3F51BA10A}">
+      <p15:sldGuideLst xmlns:p15="http://schemas.microsoft.com/office/powerpoint/2012/main"/>
+    </p:ext>
+  </p:extLst>
 </p:presentation>
 </file>
 
@@ -1556,7 +1561,7 @@
           <a:p>
             <a:fld id="{C800ED2D-9284-1147-B663-D0EB3CE3832C}" type="datetimeFigureOut">
               <a:rPr lang="en-US" smtClean="0"/>
-              <a:t>5/17/26</a:t>
+              <a:t>5/18/26</a:t>
             </a:fld>
             <a:endParaRPr lang="en-US"/>
           </a:p>
@@ -1754,7 +1759,7 @@
           <a:p>
             <a:fld id="{C800ED2D-9284-1147-B663-D0EB3CE3832C}" type="datetimeFigureOut">
               <a:rPr lang="en-US" smtClean="0"/>
-              <a:t>5/17/26</a:t>
+              <a:t>5/18/26</a:t>
             </a:fld>
             <a:endParaRPr lang="en-US"/>
           </a:p>
@@ -1962,7 +1967,7 @@
           <a:p>
             <a:fld id="{C800ED2D-9284-1147-B663-D0EB3CE3832C}" type="datetimeFigureOut">
               <a:rPr lang="en-US" smtClean="0"/>
-              <a:t>5/17/26</a:t>
+              <a:t>5/18/26</a:t>
             </a:fld>
             <a:endParaRPr lang="en-US"/>
           </a:p>
@@ -2160,7 +2165,7 @@
           <a:p>
             <a:fld id="{C800ED2D-9284-1147-B663-D0EB3CE3832C}" type="datetimeFigureOut">
               <a:rPr lang="en-US" smtClean="0"/>
-              <a:t>5/17/26</a:t>
+              <a:t>5/18/26</a:t>
             </a:fld>
             <a:endParaRPr lang="en-US"/>
           </a:p>
@@ -2435,7 +2440,7 @@
           <a:p>
             <a:fld id="{C800ED2D-9284-1147-B663-D0EB3CE3832C}" type="datetimeFigureOut">
               <a:rPr lang="en-US" smtClean="0"/>
-              <a:t>5/17/26</a:t>
+              <a:t>5/18/26</a:t>
             </a:fld>
             <a:endParaRPr lang="en-US"/>
           </a:p>
@@ -2700,7 +2705,7 @@
           <a:p>
             <a:fld id="{C800ED2D-9284-1147-B663-D0EB3CE3832C}" type="datetimeFigureOut">
               <a:rPr lang="en-US" smtClean="0"/>
-              <a:t>5/17/26</a:t>
+              <a:t>5/18/26</a:t>
             </a:fld>
             <a:endParaRPr lang="en-US"/>
           </a:p>
@@ -3112,7 +3117,7 @@
           <a:p>
             <a:fld id="{C800ED2D-9284-1147-B663-D0EB3CE3832C}" type="datetimeFigureOut">
               <a:rPr lang="en-US" smtClean="0"/>
-              <a:t>5/17/26</a:t>
+              <a:t>5/18/26</a:t>
             </a:fld>
             <a:endParaRPr lang="en-US"/>
           </a:p>
@@ -3253,7 +3258,7 @@
           <a:p>
             <a:fld id="{C800ED2D-9284-1147-B663-D0EB3CE3832C}" type="datetimeFigureOut">
               <a:rPr lang="en-US" smtClean="0"/>
-              <a:t>5/17/26</a:t>
+              <a:t>5/18/26</a:t>
             </a:fld>
             <a:endParaRPr lang="en-US"/>
           </a:p>
@@ -3366,7 +3371,7 @@
           <a:p>
             <a:fld id="{C800ED2D-9284-1147-B663-D0EB3CE3832C}" type="datetimeFigureOut">
               <a:rPr lang="en-US" smtClean="0"/>
-              <a:t>5/17/26</a:t>
+              <a:t>5/18/26</a:t>
             </a:fld>
             <a:endParaRPr lang="en-US"/>
           </a:p>
@@ -3677,7 +3682,7 @@
           <a:p>
             <a:fld id="{C800ED2D-9284-1147-B663-D0EB3CE3832C}" type="datetimeFigureOut">
               <a:rPr lang="en-US" smtClean="0"/>
-              <a:t>5/17/26</a:t>
+              <a:t>5/18/26</a:t>
             </a:fld>
             <a:endParaRPr lang="en-US"/>
           </a:p>
@@ -3965,7 +3970,7 @@
           <a:p>
             <a:fld id="{C800ED2D-9284-1147-B663-D0EB3CE3832C}" type="datetimeFigureOut">
               <a:rPr lang="en-US" smtClean="0"/>
-              <a:t>5/17/26</a:t>
+              <a:t>5/18/26</a:t>
             </a:fld>
             <a:endParaRPr lang="en-US"/>
           </a:p>
@@ -4206,7 +4211,7 @@
           <a:p>
             <a:fld id="{C800ED2D-9284-1147-B663-D0EB3CE3832C}" type="datetimeFigureOut">
               <a:rPr lang="en-US" smtClean="0"/>
-              <a:t>5/17/26</a:t>
+              <a:t>5/18/26</a:t>
             </a:fld>
             <a:endParaRPr lang="en-US"/>
           </a:p>
@@ -6183,7 +6188,7 @@
         <p:spPr>
           <a:xfrm>
             <a:off x="8483600" y="4381500"/>
-            <a:ext cx="2921000" cy="279400"/>
+            <a:ext cx="2921000" cy="307777"/>
           </a:xfrm>
           <a:prstGeom prst="rect">
             <a:avLst/>
@@ -6198,15 +6203,22 @@
           <a:p>
             <a:pPr algn="l"/>
             <a:r>
-              <a:rPr lang="en-US" sz="1400" b="1">
+              <a:rPr lang="en-US" sz="1400" b="1" dirty="0" err="1">
                 <a:solidFill>
                   <a:srgbClr val="1A1F2E"/>
                 </a:solidFill>
                 <a:latin typeface="Segoe UI Semibold"/>
                 <a:cs typeface="Segoe UI Semibold"/>
               </a:rPr>
-              <a:t>Bulk + agregacija</a:t>
-            </a:r>
+              <a:t>Agregacija</a:t>
+            </a:r>
+            <a:endParaRPr lang="en-US" sz="1400" b="1" dirty="0">
+              <a:solidFill>
+                <a:srgbClr val="1A1F2E"/>
+              </a:solidFill>
+              <a:latin typeface="Segoe UI Semibold"/>
+              <a:cs typeface="Segoe UI Semibold"/>
+            </a:endParaRPr>
           </a:p>
         </p:txBody>
       </p:sp>
@@ -6225,7 +6237,7 @@
         <p:spPr>
           <a:xfrm>
             <a:off x="8483600" y="4660900"/>
-            <a:ext cx="2921000" cy="558800"/>
+            <a:ext cx="2921000" cy="261610"/>
           </a:xfrm>
           <a:prstGeom prst="rect">
             <a:avLst/>
@@ -6240,15 +6252,62 @@
           <a:p>
             <a:pPr algn="l"/>
             <a:r>
-              <a:rPr lang="en-US" sz="1100">
+              <a:rPr lang="en-US" sz="1100" dirty="0" err="1">
                 <a:solidFill>
                   <a:srgbClr val="5B7C99"/>
                 </a:solidFill>
                 <a:latin typeface="Segoe UI"/>
                 <a:cs typeface="Segoe UI"/>
               </a:rPr>
-              <a:t>Paketsko upisivanje i upiti visokog opterećenja</a:t>
-            </a:r>
+              <a:t>Upiti</a:t>
+            </a:r>
+            <a:r>
+              <a:rPr lang="en-US" sz="1100" dirty="0">
+                <a:solidFill>
+                  <a:srgbClr val="5B7C99"/>
+                </a:solidFill>
+                <a:latin typeface="Segoe UI"/>
+                <a:cs typeface="Segoe UI"/>
+              </a:rPr>
+              <a:t> </a:t>
+            </a:r>
+            <a:r>
+              <a:rPr lang="en-US" sz="1100" dirty="0" err="1">
+                <a:solidFill>
+                  <a:srgbClr val="5B7C99"/>
+                </a:solidFill>
+                <a:latin typeface="Segoe UI"/>
+                <a:cs typeface="Segoe UI"/>
+              </a:rPr>
+              <a:t>visokog</a:t>
+            </a:r>
+            <a:r>
+              <a:rPr lang="en-US" sz="1100" dirty="0">
+                <a:solidFill>
+                  <a:srgbClr val="5B7C99"/>
+                </a:solidFill>
+                <a:latin typeface="Segoe UI"/>
+                <a:cs typeface="Segoe UI"/>
+              </a:rPr>
+              <a:t> </a:t>
+            </a:r>
+            <a:r>
+              <a:rPr lang="en-US" sz="1100" dirty="0" err="1">
+                <a:solidFill>
+                  <a:srgbClr val="5B7C99"/>
+                </a:solidFill>
+                <a:latin typeface="Segoe UI"/>
+                <a:cs typeface="Segoe UI"/>
+              </a:rPr>
+              <a:t>opterećenja</a:t>
+            </a:r>
+            <a:endParaRPr lang="en-US" sz="1100" dirty="0">
+              <a:solidFill>
+                <a:srgbClr val="5B7C99"/>
+              </a:solidFill>
+              <a:latin typeface="Segoe UI"/>
+              <a:cs typeface="Segoe UI"/>
+            </a:endParaRPr>
           </a:p>
         </p:txBody>
       </p:sp>

</xml_diff>